<commit_message>
Built FretboardCNN and fretboard evaluation
</commit_message>
<xml_diff>
--- a/docs/Meetings/Guitar tool presentation 1.pptx
+++ b/docs/Meetings/Guitar tool presentation 1.pptx
@@ -6,13 +6,14 @@
   </p:sldMasterIdLst>
   <p:sldIdLst>
     <p:sldId id="256" r:id="rId2"/>
-    <p:sldId id="258" r:id="rId3"/>
-    <p:sldId id="259" r:id="rId4"/>
-    <p:sldId id="260" r:id="rId5"/>
-    <p:sldId id="261" r:id="rId6"/>
-    <p:sldId id="262" r:id="rId7"/>
-    <p:sldId id="257" r:id="rId8"/>
-    <p:sldId id="263" r:id="rId9"/>
+    <p:sldId id="264" r:id="rId3"/>
+    <p:sldId id="265" r:id="rId4"/>
+    <p:sldId id="257" r:id="rId5"/>
+    <p:sldId id="259" r:id="rId6"/>
+    <p:sldId id="260" r:id="rId7"/>
+    <p:sldId id="261" r:id="rId8"/>
+    <p:sldId id="262" r:id="rId9"/>
+    <p:sldId id="263" r:id="rId10"/>
   </p:sldIdLst>
   <p:sldSz cx="12192000" cy="6858000"/>
   <p:notesSz cx="6858000" cy="9144000"/>
@@ -272,7 +273,7 @@
           <a:p>
             <a:fld id="{C128FA71-3A18-48C0-980F-4B68F7F63042}" type="datetime1">
               <a:rPr lang="en-US" smtClean="0"/>
-              <a:t>11/12/2025</a:t>
+              <a:t>11/19/2025</a:t>
             </a:fld>
             <a:endParaRPr lang="en-US"/>
           </a:p>
@@ -480,7 +481,7 @@
           <a:p>
             <a:fld id="{7104EDB3-C0E8-45F8-9E1D-1B6C8D1880C0}" type="datetime1">
               <a:rPr lang="en-US" smtClean="0"/>
-              <a:t>11/12/2025</a:t>
+              <a:t>11/19/2025</a:t>
             </a:fld>
             <a:endParaRPr lang="en-US"/>
           </a:p>
@@ -690,7 +691,7 @@
           <a:p>
             <a:fld id="{9CF0EC4B-54ED-4041-B552-9BA760FA3DBA}" type="datetime1">
               <a:rPr lang="en-US" smtClean="0"/>
-              <a:t>11/12/2025</a:t>
+              <a:t>11/19/2025</a:t>
             </a:fld>
             <a:endParaRPr lang="en-US"/>
           </a:p>
@@ -888,7 +889,7 @@
           <a:p>
             <a:fld id="{51C1210E-201E-4473-82AC-2466F5386C38}" type="datetime1">
               <a:rPr lang="en-US" smtClean="0"/>
-              <a:t>11/12/2025</a:t>
+              <a:t>11/19/2025</a:t>
             </a:fld>
             <a:endParaRPr lang="en-US"/>
           </a:p>
@@ -1166,7 +1167,7 @@
           <a:p>
             <a:fld id="{B01EA198-6CAB-4B8F-B93F-1F9C8C4B6CE7}" type="datetime1">
               <a:rPr lang="en-US" smtClean="0"/>
-              <a:t>11/12/2025</a:t>
+              <a:t>11/19/2025</a:t>
             </a:fld>
             <a:endParaRPr lang="en-US"/>
           </a:p>
@@ -1438,7 +1439,7 @@
           <a:p>
             <a:fld id="{CA06041F-4525-44D5-AA4F-332294BF1F56}" type="datetime1">
               <a:rPr lang="en-US" smtClean="0"/>
-              <a:t>11/12/2025</a:t>
+              <a:t>11/19/2025</a:t>
             </a:fld>
             <a:endParaRPr lang="en-US"/>
           </a:p>
@@ -1862,7 +1863,7 @@
           <a:p>
             <a:fld id="{F9557091-BBDF-4EB9-BA6B-2BB67AC4FC0F}" type="datetime1">
               <a:rPr lang="en-US" smtClean="0"/>
-              <a:t>11/12/2025</a:t>
+              <a:t>11/19/2025</a:t>
             </a:fld>
             <a:endParaRPr lang="en-US"/>
           </a:p>
@@ -2003,7 +2004,7 @@
           <a:p>
             <a:fld id="{2D6B226B-77A6-410C-9796-083F278E0125}" type="datetime1">
               <a:rPr lang="en-US" smtClean="0"/>
-              <a:t>11/12/2025</a:t>
+              <a:t>11/19/2025</a:t>
             </a:fld>
             <a:endParaRPr lang="en-US"/>
           </a:p>
@@ -2116,7 +2117,7 @@
           <a:p>
             <a:fld id="{A23A578B-D289-4C40-8593-3D356C49DA58}" type="datetime1">
               <a:rPr lang="en-US" smtClean="0"/>
-              <a:t>11/12/2025</a:t>
+              <a:t>11/19/2025</a:t>
             </a:fld>
             <a:endParaRPr lang="en-US"/>
           </a:p>
@@ -2435,7 +2436,7 @@
           <a:p>
             <a:fld id="{713DFAE3-14DB-48A7-A80F-80DDB072CE3D}" type="datetime1">
               <a:rPr lang="en-US" smtClean="0"/>
-              <a:t>11/12/2025</a:t>
+              <a:t>11/19/2025</a:t>
             </a:fld>
             <a:endParaRPr lang="en-US"/>
           </a:p>
@@ -2729,7 +2730,7 @@
           <a:p>
             <a:fld id="{92C5EAEF-6478-4102-8F5D-A5FE9FC97ACB}" type="datetime1">
               <a:rPr lang="en-US" smtClean="0"/>
-              <a:t>11/12/2025</a:t>
+              <a:t>11/19/2025</a:t>
             </a:fld>
             <a:endParaRPr lang="en-US"/>
           </a:p>
@@ -2970,7 +2971,7 @@
           <a:p>
             <a:fld id="{67F45AC6-C491-4585-A584-9CE2AF7D5500}" type="datetime1">
               <a:rPr lang="en-US" smtClean="0"/>
-              <a:t>11/12/2025</a:t>
+              <a:t>11/19/2025</a:t>
             </a:fld>
             <a:endParaRPr lang="en-US"/>
           </a:p>
@@ -3373,7 +3374,7 @@
     <p:bg>
       <p:bgPr>
         <a:solidFill>
-          <a:schemeClr val="bg1"/>
+          <a:srgbClr val="FFFCF7"/>
         </a:solidFill>
         <a:effectLst/>
       </p:bgPr>
@@ -3670,7 +3671,7 @@
           <p:cNvPr id="2" name="Title 1">
             <a:extLst>
               <a:ext uri="{FF2B5EF4-FFF2-40B4-BE49-F238E27FC236}">
-                <a16:creationId xmlns:a16="http://schemas.microsoft.com/office/drawing/2014/main" id="{E82A0D69-F67C-CF79-8AA3-67D28A6BBB5F}"/>
+                <a16:creationId xmlns:a16="http://schemas.microsoft.com/office/drawing/2014/main" id="{A729C821-CE08-BA2D-0BAD-19D56CFDA9C2}"/>
               </a:ext>
             </a:extLst>
           </p:cNvPr>
@@ -3681,60 +3682,399 @@
             <p:ph type="title"/>
           </p:nvPr>
         </p:nvSpPr>
-        <p:spPr/>
+        <p:spPr>
+          <a:xfrm>
+            <a:off x="612648" y="548640"/>
+            <a:ext cx="4655638" cy="1132258"/>
+          </a:xfrm>
+        </p:spPr>
+        <p:txBody>
+          <a:bodyPr>
+            <a:normAutofit/>
+          </a:bodyPr>
+          <a:lstStyle/>
+          <a:p>
+            <a:r>
+              <a:rPr lang="en-GB" sz="2400" dirty="0"/>
+              <a:t>Guitar on Audio Transcription Dataset (GOAT)</a:t>
+            </a:r>
+          </a:p>
+        </p:txBody>
+      </p:sp>
+      <p:sp>
+        <p:nvSpPr>
+          <p:cNvPr id="3" name="Content Placeholder 2">
+            <a:extLst>
+              <a:ext uri="{FF2B5EF4-FFF2-40B4-BE49-F238E27FC236}">
+                <a16:creationId xmlns:a16="http://schemas.microsoft.com/office/drawing/2014/main" id="{D7534D9B-A771-9698-4576-111EADC1991E}"/>
+              </a:ext>
+            </a:extLst>
+          </p:cNvPr>
+          <p:cNvSpPr>
+            <a:spLocks noGrp="1"/>
+          </p:cNvSpPr>
+          <p:nvPr>
+            <p:ph idx="1"/>
+          </p:nvPr>
+        </p:nvSpPr>
+        <p:spPr>
+          <a:xfrm>
+            <a:off x="612648" y="1794253"/>
+            <a:ext cx="4465539" cy="4593828"/>
+          </a:xfrm>
+        </p:spPr>
         <p:txBody>
           <a:bodyPr/>
           <a:lstStyle/>
           <a:p>
             <a:r>
               <a:rPr lang="en-GB" dirty="0"/>
-              <a:t>Evaluation Metric</a:t>
-            </a:r>
-          </a:p>
-        </p:txBody>
-      </p:sp>
-      <p:sp>
-        <p:nvSpPr>
-          <p:cNvPr id="3" name="Content Placeholder 2">
-            <a:extLst>
-              <a:ext uri="{FF2B5EF4-FFF2-40B4-BE49-F238E27FC236}">
-                <a16:creationId xmlns:a16="http://schemas.microsoft.com/office/drawing/2014/main" id="{03DD3668-E357-36EE-18E5-7636C109CA78}"/>
-              </a:ext>
-            </a:extLst>
-          </p:cNvPr>
-          <p:cNvSpPr>
-            <a:spLocks noGrp="1"/>
-          </p:cNvSpPr>
-          <p:nvPr>
-            <p:ph idx="1"/>
-          </p:nvPr>
-        </p:nvSpPr>
-        <p:spPr/>
-        <p:txBody>
-          <a:bodyPr/>
-          <a:lstStyle/>
-          <a:p>
-            <a:r>
-              <a:rPr lang="en-GB" dirty="0"/>
-              <a:t>Basic version – Pitch</a:t>
-            </a:r>
-          </a:p>
-          <a:p>
+              <a:t>5.9 hours of unique, Direct Input audio using various electric guitars and players</a:t>
+            </a:r>
+          </a:p>
+          <a:p>
+            <a:r>
+              <a:rPr lang="en-GB" dirty="0"/>
+              <a:t>Includes string and fret numbers </a:t>
+            </a:r>
+          </a:p>
+          <a:p>
+            <a:r>
+              <a:rPr lang="en-GB" dirty="0"/>
+              <a:t>Requires to request access due to using covers of popular songs (Emailed the research member)</a:t>
+            </a:r>
+          </a:p>
+        </p:txBody>
+      </p:sp>
+      <p:sp>
+        <p:nvSpPr>
+          <p:cNvPr id="4" name="Title 1">
+            <a:extLst>
+              <a:ext uri="{FF2B5EF4-FFF2-40B4-BE49-F238E27FC236}">
+                <a16:creationId xmlns:a16="http://schemas.microsoft.com/office/drawing/2014/main" id="{6985DC3B-ED89-399C-73E6-2E71FBCEA53A}"/>
+              </a:ext>
+            </a:extLst>
+          </p:cNvPr>
+          <p:cNvSpPr txBox="1">
+            <a:spLocks/>
+          </p:cNvSpPr>
+          <p:nvPr/>
+        </p:nvSpPr>
+        <p:spPr>
+          <a:xfrm>
+            <a:off x="5990199" y="586737"/>
+            <a:ext cx="4655638" cy="1132258"/>
+          </a:xfrm>
+          <a:prstGeom prst="rect">
+            <a:avLst/>
+          </a:prstGeom>
+        </p:spPr>
+        <p:txBody>
+          <a:bodyPr vert="horz" lIns="91440" tIns="45720" rIns="91440" bIns="45720" rtlCol="0" anchor="t">
+            <a:normAutofit/>
+          </a:bodyPr>
+          <a:lstStyle>
+            <a:lvl1pPr algn="l" defTabSz="914400" rtl="0" eaLnBrk="1" latinLnBrk="0" hangingPunct="1">
+              <a:lnSpc>
+                <a:spcPct val="90000"/>
+              </a:lnSpc>
+              <a:spcBef>
+                <a:spcPct val="0"/>
+              </a:spcBef>
+              <a:buNone/>
+              <a:defRPr sz="3600" b="1" kern="1200">
+                <a:solidFill>
+                  <a:schemeClr val="tx1"/>
+                </a:solidFill>
+                <a:latin typeface="+mj-lt"/>
+                <a:ea typeface="+mj-ea"/>
+                <a:cs typeface="+mj-cs"/>
+              </a:defRPr>
+            </a:lvl1pPr>
+          </a:lstStyle>
+          <a:p>
+            <a:r>
+              <a:rPr lang="en-GB" sz="2400" dirty="0" err="1"/>
+              <a:t>SynthTab</a:t>
+            </a:r>
+            <a:endParaRPr lang="en-GB" sz="2400" dirty="0"/>
+          </a:p>
+        </p:txBody>
+      </p:sp>
+      <p:sp>
+        <p:nvSpPr>
+          <p:cNvPr id="5" name="Content Placeholder 2">
+            <a:extLst>
+              <a:ext uri="{FF2B5EF4-FFF2-40B4-BE49-F238E27FC236}">
+                <a16:creationId xmlns:a16="http://schemas.microsoft.com/office/drawing/2014/main" id="{AEC27EE5-CC9A-F48C-24F3-60B7D025E5F0}"/>
+              </a:ext>
+            </a:extLst>
+          </p:cNvPr>
+          <p:cNvSpPr txBox="1">
+            <a:spLocks/>
+          </p:cNvSpPr>
+          <p:nvPr/>
+        </p:nvSpPr>
+        <p:spPr>
+          <a:xfrm>
+            <a:off x="5516669" y="1794253"/>
+            <a:ext cx="4465539" cy="4593828"/>
+          </a:xfrm>
+          <a:prstGeom prst="rect">
+            <a:avLst/>
+          </a:prstGeom>
+        </p:spPr>
+        <p:txBody>
+          <a:bodyPr vert="horz" lIns="91440" tIns="45720" rIns="91440" bIns="45720" rtlCol="0">
+            <a:normAutofit/>
+          </a:bodyPr>
+          <a:lstStyle>
+            <a:lvl1pPr marL="228600" indent="-228600" algn="l" defTabSz="914400" rtl="0" eaLnBrk="1" latinLnBrk="0" hangingPunct="1">
+              <a:lnSpc>
+                <a:spcPct val="120000"/>
+              </a:lnSpc>
+              <a:spcBef>
+                <a:spcPts val="1000"/>
+              </a:spcBef>
+              <a:buFont typeface="Arial" panose="020B0604020202020204" pitchFamily="34" charset="0"/>
+              <a:buChar char="•"/>
+              <a:defRPr sz="2000" kern="1200">
+                <a:solidFill>
+                  <a:schemeClr val="tx1"/>
+                </a:solidFill>
+                <a:latin typeface="+mn-lt"/>
+                <a:ea typeface="+mn-ea"/>
+                <a:cs typeface="+mn-cs"/>
+              </a:defRPr>
+            </a:lvl1pPr>
+            <a:lvl2pPr marL="457200" indent="-228600" algn="l" defTabSz="914400" rtl="0" eaLnBrk="1" latinLnBrk="0" hangingPunct="1">
+              <a:lnSpc>
+                <a:spcPct val="120000"/>
+              </a:lnSpc>
+              <a:spcBef>
+                <a:spcPts val="500"/>
+              </a:spcBef>
+              <a:buFont typeface="Arial" panose="020B0604020202020204" pitchFamily="34" charset="0"/>
+              <a:buChar char="•"/>
+              <a:defRPr sz="1800" kern="1200">
+                <a:solidFill>
+                  <a:schemeClr val="tx1"/>
+                </a:solidFill>
+                <a:latin typeface="+mn-lt"/>
+                <a:ea typeface="+mn-ea"/>
+                <a:cs typeface="+mn-cs"/>
+              </a:defRPr>
+            </a:lvl2pPr>
+            <a:lvl3pPr marL="685800" indent="-228600" algn="l" defTabSz="914400" rtl="0" eaLnBrk="1" latinLnBrk="0" hangingPunct="1">
+              <a:lnSpc>
+                <a:spcPct val="120000"/>
+              </a:lnSpc>
+              <a:spcBef>
+                <a:spcPts val="500"/>
+              </a:spcBef>
+              <a:buFont typeface="Arial" panose="020B0604020202020204" pitchFamily="34" charset="0"/>
+              <a:buChar char="•"/>
+              <a:defRPr sz="1600" kern="1200">
+                <a:solidFill>
+                  <a:schemeClr val="tx1"/>
+                </a:solidFill>
+                <a:latin typeface="+mn-lt"/>
+                <a:ea typeface="+mn-ea"/>
+                <a:cs typeface="+mn-cs"/>
+              </a:defRPr>
+            </a:lvl3pPr>
+            <a:lvl4pPr marL="914400" indent="-228600" algn="l" defTabSz="914400" rtl="0" eaLnBrk="1" latinLnBrk="0" hangingPunct="1">
+              <a:lnSpc>
+                <a:spcPct val="120000"/>
+              </a:lnSpc>
+              <a:spcBef>
+                <a:spcPts val="500"/>
+              </a:spcBef>
+              <a:buFont typeface="Arial" panose="020B0604020202020204" pitchFamily="34" charset="0"/>
+              <a:buChar char="•"/>
+              <a:defRPr sz="1400" kern="1200">
+                <a:solidFill>
+                  <a:schemeClr val="tx1"/>
+                </a:solidFill>
+                <a:latin typeface="+mn-lt"/>
+                <a:ea typeface="+mn-ea"/>
+                <a:cs typeface="+mn-cs"/>
+              </a:defRPr>
+            </a:lvl4pPr>
+            <a:lvl5pPr marL="1143000" indent="-228600" algn="l" defTabSz="914400" rtl="0" eaLnBrk="1" latinLnBrk="0" hangingPunct="1">
+              <a:lnSpc>
+                <a:spcPct val="120000"/>
+              </a:lnSpc>
+              <a:spcBef>
+                <a:spcPts val="500"/>
+              </a:spcBef>
+              <a:buFont typeface="Arial" panose="020B0604020202020204" pitchFamily="34" charset="0"/>
+              <a:buChar char="•"/>
+              <a:defRPr sz="1200" kern="1200">
+                <a:solidFill>
+                  <a:schemeClr val="tx1"/>
+                </a:solidFill>
+                <a:latin typeface="+mn-lt"/>
+                <a:ea typeface="+mn-ea"/>
+                <a:cs typeface="+mn-cs"/>
+              </a:defRPr>
+            </a:lvl5pPr>
+            <a:lvl6pPr marL="2514600" indent="-228600" algn="l" defTabSz="914400" rtl="0" eaLnBrk="1" latinLnBrk="0" hangingPunct="1">
+              <a:lnSpc>
+                <a:spcPct val="90000"/>
+              </a:lnSpc>
+              <a:spcBef>
+                <a:spcPts val="500"/>
+              </a:spcBef>
+              <a:buFont typeface="Arial" panose="020B0604020202020204" pitchFamily="34" charset="0"/>
+              <a:buChar char="•"/>
+              <a:defRPr sz="1800" kern="1200">
+                <a:solidFill>
+                  <a:schemeClr val="tx1"/>
+                </a:solidFill>
+                <a:latin typeface="+mn-lt"/>
+                <a:ea typeface="+mn-ea"/>
+                <a:cs typeface="+mn-cs"/>
+              </a:defRPr>
+            </a:lvl6pPr>
+            <a:lvl7pPr marL="2971800" indent="-228600" algn="l" defTabSz="914400" rtl="0" eaLnBrk="1" latinLnBrk="0" hangingPunct="1">
+              <a:lnSpc>
+                <a:spcPct val="90000"/>
+              </a:lnSpc>
+              <a:spcBef>
+                <a:spcPts val="500"/>
+              </a:spcBef>
+              <a:buFont typeface="Arial" panose="020B0604020202020204" pitchFamily="34" charset="0"/>
+              <a:buChar char="•"/>
+              <a:defRPr sz="1800" kern="1200">
+                <a:solidFill>
+                  <a:schemeClr val="tx1"/>
+                </a:solidFill>
+                <a:latin typeface="+mn-lt"/>
+                <a:ea typeface="+mn-ea"/>
+                <a:cs typeface="+mn-cs"/>
+              </a:defRPr>
+            </a:lvl7pPr>
+            <a:lvl8pPr marL="3429000" indent="-228600" algn="l" defTabSz="914400" rtl="0" eaLnBrk="1" latinLnBrk="0" hangingPunct="1">
+              <a:lnSpc>
+                <a:spcPct val="90000"/>
+              </a:lnSpc>
+              <a:spcBef>
+                <a:spcPts val="500"/>
+              </a:spcBef>
+              <a:buFont typeface="Arial" panose="020B0604020202020204" pitchFamily="34" charset="0"/>
+              <a:buChar char="•"/>
+              <a:defRPr sz="1800" kern="1200">
+                <a:solidFill>
+                  <a:schemeClr val="tx1"/>
+                </a:solidFill>
+                <a:latin typeface="+mn-lt"/>
+                <a:ea typeface="+mn-ea"/>
+                <a:cs typeface="+mn-cs"/>
+              </a:defRPr>
+            </a:lvl8pPr>
+            <a:lvl9pPr marL="3886200" indent="-228600" algn="l" defTabSz="914400" rtl="0" eaLnBrk="1" latinLnBrk="0" hangingPunct="1">
+              <a:lnSpc>
+                <a:spcPct val="90000"/>
+              </a:lnSpc>
+              <a:spcBef>
+                <a:spcPts val="500"/>
+              </a:spcBef>
+              <a:buFont typeface="Arial" panose="020B0604020202020204" pitchFamily="34" charset="0"/>
+              <a:buChar char="•"/>
+              <a:defRPr sz="1800" kern="1200">
+                <a:solidFill>
+                  <a:schemeClr val="tx1"/>
+                </a:solidFill>
+                <a:latin typeface="+mn-lt"/>
+                <a:ea typeface="+mn-ea"/>
+                <a:cs typeface="+mn-cs"/>
+              </a:defRPr>
+            </a:lvl9pPr>
+          </a:lstStyle>
+          <a:p>
+            <a:r>
+              <a:rPr lang="en-GB" dirty="0"/>
+              <a:t>13 hours of synthesised guitar audio (attempts to simulate human playing)</a:t>
+            </a:r>
+          </a:p>
+          <a:p>
+            <a:r>
+              <a:rPr lang="en-GB" dirty="0"/>
+              <a:t>Using </a:t>
+            </a:r>
             <a:r>
               <a:rPr lang="en-GB" dirty="0" err="1"/>
-              <a:t>GuitarSet</a:t>
-            </a:r>
-            <a:endParaRPr lang="en-GB" dirty="0"/>
-          </a:p>
-          <a:p>
-            <a:endParaRPr lang="en-GB" dirty="0"/>
+              <a:t>DadaGP</a:t>
+            </a:r>
+            <a:r>
+              <a:rPr lang="en-GB" dirty="0"/>
+              <a:t> dataset </a:t>
+            </a:r>
+          </a:p>
+          <a:p>
+            <a:r>
+              <a:rPr lang="en-GB" dirty="0"/>
+              <a:t>String accurate and perfectly aligned with the ground truth tablature annotations</a:t>
+            </a:r>
+          </a:p>
+        </p:txBody>
+      </p:sp>
+      <p:sp>
+        <p:nvSpPr>
+          <p:cNvPr id="6" name="TextBox 5">
+            <a:extLst>
+              <a:ext uri="{FF2B5EF4-FFF2-40B4-BE49-F238E27FC236}">
+                <a16:creationId xmlns:a16="http://schemas.microsoft.com/office/drawing/2014/main" id="{04BAC066-2216-B094-657C-7587BFD46B62}"/>
+              </a:ext>
+            </a:extLst>
+          </p:cNvPr>
+          <p:cNvSpPr txBox="1"/>
+          <p:nvPr/>
+        </p:nvSpPr>
+        <p:spPr>
+          <a:xfrm>
+            <a:off x="369116" y="5108895"/>
+            <a:ext cx="11210236" cy="923330"/>
+          </a:xfrm>
+          <a:prstGeom prst="rect">
+            <a:avLst/>
+          </a:prstGeom>
+          <a:noFill/>
+        </p:spPr>
+        <p:txBody>
+          <a:bodyPr wrap="square" rtlCol="0">
+            <a:spAutoFit/>
+          </a:bodyPr>
+          <a:lstStyle/>
+          <a:p>
+            <a:r>
+              <a:rPr lang="en-GB" dirty="0"/>
+              <a:t>Main issue large folders</a:t>
+            </a:r>
+          </a:p>
+          <a:p>
+            <a:r>
+              <a:rPr lang="en-GB" dirty="0" err="1"/>
+              <a:t>SynthTab</a:t>
+            </a:r>
+            <a:r>
+              <a:rPr lang="en-GB" dirty="0"/>
+              <a:t>: 2TB</a:t>
+            </a:r>
+          </a:p>
+          <a:p>
+            <a:r>
+              <a:rPr lang="en-GB" dirty="0"/>
+              <a:t>GOAT: 500GB</a:t>
+            </a:r>
           </a:p>
         </p:txBody>
       </p:sp>
     </p:spTree>
     <p:extLst>
       <p:ext uri="{BB962C8B-B14F-4D97-AF65-F5344CB8AC3E}">
-        <p14:creationId xmlns:p14="http://schemas.microsoft.com/office/powerpoint/2010/main" val="393045412"/>
+        <p14:creationId xmlns:p14="http://schemas.microsoft.com/office/powerpoint/2010/main" val="3372884642"/>
       </p:ext>
     </p:extLst>
   </p:cSld>
@@ -3774,7 +4114,7 @@
           <p:cNvPr id="2" name="Title 1">
             <a:extLst>
               <a:ext uri="{FF2B5EF4-FFF2-40B4-BE49-F238E27FC236}">
-                <a16:creationId xmlns:a16="http://schemas.microsoft.com/office/drawing/2014/main" id="{B8218398-494E-FA07-F0B2-F5F640928F92}"/>
+                <a16:creationId xmlns:a16="http://schemas.microsoft.com/office/drawing/2014/main" id="{B91524E0-CF45-C492-1586-FF6577E80976}"/>
               </a:ext>
             </a:extLst>
           </p:cNvPr>
@@ -3792,7 +4132,7 @@
           <a:p>
             <a:r>
               <a:rPr lang="en-GB" dirty="0"/>
-              <a:t>Basic Pitch (Control)</a:t>
+              <a:t>Approaches of Automatic Guitar Transcription (AGT)</a:t>
             </a:r>
           </a:p>
         </p:txBody>
@@ -3802,7 +4142,7 @@
           <p:cNvPr id="3" name="Content Placeholder 2">
             <a:extLst>
               <a:ext uri="{FF2B5EF4-FFF2-40B4-BE49-F238E27FC236}">
-                <a16:creationId xmlns:a16="http://schemas.microsoft.com/office/drawing/2014/main" id="{E85D6C78-A73B-07E2-DB5B-377EA74CEF88}"/>
+                <a16:creationId xmlns:a16="http://schemas.microsoft.com/office/drawing/2014/main" id="{AA10EDC2-B06F-4D7C-EDC4-C719C185C86C}"/>
               </a:ext>
             </a:extLst>
           </p:cNvPr>
@@ -3813,19 +4153,290 @@
             <p:ph idx="1"/>
           </p:nvPr>
         </p:nvSpPr>
-        <p:spPr/>
+        <p:spPr>
+          <a:xfrm>
+            <a:off x="612647" y="1715532"/>
+            <a:ext cx="4416553" cy="3770868"/>
+          </a:xfrm>
+        </p:spPr>
         <p:txBody>
           <a:bodyPr/>
           <a:lstStyle/>
           <a:p>
-            <a:endParaRPr lang="en-GB"/>
+            <a:pPr marL="0" indent="0">
+              <a:buNone/>
+            </a:pPr>
+            <a:r>
+              <a:rPr lang="en-GB" dirty="0" err="1"/>
+              <a:t>TabCNN</a:t>
+            </a:r>
+            <a:r>
+              <a:rPr lang="en-GB" dirty="0"/>
+              <a:t> (end-to-end solution)</a:t>
+            </a:r>
+          </a:p>
+          <a:p>
+            <a:r>
+              <a:rPr lang="en-GB" dirty="0"/>
+              <a:t>Solves both the problems of pitch estimation and fretboard mapping</a:t>
+            </a:r>
+          </a:p>
+          <a:p>
+            <a:r>
+              <a:rPr lang="en-GB" dirty="0"/>
+              <a:t>Predicts actual fingering of guitarist </a:t>
+            </a:r>
+          </a:p>
+          <a:p>
+            <a:r>
+              <a:rPr lang="en-GB" dirty="0"/>
+              <a:t>Trained on </a:t>
+            </a:r>
+            <a:r>
+              <a:rPr lang="en-GB" dirty="0" err="1"/>
+              <a:t>GuitarSet</a:t>
+            </a:r>
+            <a:endParaRPr lang="en-GB" dirty="0"/>
+          </a:p>
+          <a:p>
+            <a:r>
+              <a:rPr lang="en-GB" dirty="0"/>
+              <a:t>Not explicitly designed for guitar techniques</a:t>
+            </a:r>
+          </a:p>
+        </p:txBody>
+      </p:sp>
+      <p:sp>
+        <p:nvSpPr>
+          <p:cNvPr id="4" name="Content Placeholder 2">
+            <a:extLst>
+              <a:ext uri="{FF2B5EF4-FFF2-40B4-BE49-F238E27FC236}">
+                <a16:creationId xmlns:a16="http://schemas.microsoft.com/office/drawing/2014/main" id="{6ABDB94A-3A66-E218-3C8D-C45D282E6FA6}"/>
+              </a:ext>
+            </a:extLst>
+          </p:cNvPr>
+          <p:cNvSpPr txBox="1">
+            <a:spLocks/>
+          </p:cNvSpPr>
+          <p:nvPr/>
+        </p:nvSpPr>
+        <p:spPr>
+          <a:xfrm>
+            <a:off x="5834596" y="1676914"/>
+            <a:ext cx="4416553" cy="3504171"/>
+          </a:xfrm>
+          <a:prstGeom prst="rect">
+            <a:avLst/>
+          </a:prstGeom>
+        </p:spPr>
+        <p:txBody>
+          <a:bodyPr vert="horz" lIns="91440" tIns="45720" rIns="91440" bIns="45720" rtlCol="0">
+            <a:normAutofit/>
+          </a:bodyPr>
+          <a:lstStyle>
+            <a:lvl1pPr marL="228600" indent="-228600" algn="l" defTabSz="914400" rtl="0" eaLnBrk="1" latinLnBrk="0" hangingPunct="1">
+              <a:lnSpc>
+                <a:spcPct val="120000"/>
+              </a:lnSpc>
+              <a:spcBef>
+                <a:spcPts val="1000"/>
+              </a:spcBef>
+              <a:buFont typeface="Arial" panose="020B0604020202020204" pitchFamily="34" charset="0"/>
+              <a:buChar char="•"/>
+              <a:defRPr sz="2000" kern="1200">
+                <a:solidFill>
+                  <a:schemeClr val="tx1"/>
+                </a:solidFill>
+                <a:latin typeface="+mn-lt"/>
+                <a:ea typeface="+mn-ea"/>
+                <a:cs typeface="+mn-cs"/>
+              </a:defRPr>
+            </a:lvl1pPr>
+            <a:lvl2pPr marL="457200" indent="-228600" algn="l" defTabSz="914400" rtl="0" eaLnBrk="1" latinLnBrk="0" hangingPunct="1">
+              <a:lnSpc>
+                <a:spcPct val="120000"/>
+              </a:lnSpc>
+              <a:spcBef>
+                <a:spcPts val="500"/>
+              </a:spcBef>
+              <a:buFont typeface="Arial" panose="020B0604020202020204" pitchFamily="34" charset="0"/>
+              <a:buChar char="•"/>
+              <a:defRPr sz="1800" kern="1200">
+                <a:solidFill>
+                  <a:schemeClr val="tx1"/>
+                </a:solidFill>
+                <a:latin typeface="+mn-lt"/>
+                <a:ea typeface="+mn-ea"/>
+                <a:cs typeface="+mn-cs"/>
+              </a:defRPr>
+            </a:lvl2pPr>
+            <a:lvl3pPr marL="685800" indent="-228600" algn="l" defTabSz="914400" rtl="0" eaLnBrk="1" latinLnBrk="0" hangingPunct="1">
+              <a:lnSpc>
+                <a:spcPct val="120000"/>
+              </a:lnSpc>
+              <a:spcBef>
+                <a:spcPts val="500"/>
+              </a:spcBef>
+              <a:buFont typeface="Arial" panose="020B0604020202020204" pitchFamily="34" charset="0"/>
+              <a:buChar char="•"/>
+              <a:defRPr sz="1600" kern="1200">
+                <a:solidFill>
+                  <a:schemeClr val="tx1"/>
+                </a:solidFill>
+                <a:latin typeface="+mn-lt"/>
+                <a:ea typeface="+mn-ea"/>
+                <a:cs typeface="+mn-cs"/>
+              </a:defRPr>
+            </a:lvl3pPr>
+            <a:lvl4pPr marL="914400" indent="-228600" algn="l" defTabSz="914400" rtl="0" eaLnBrk="1" latinLnBrk="0" hangingPunct="1">
+              <a:lnSpc>
+                <a:spcPct val="120000"/>
+              </a:lnSpc>
+              <a:spcBef>
+                <a:spcPts val="500"/>
+              </a:spcBef>
+              <a:buFont typeface="Arial" panose="020B0604020202020204" pitchFamily="34" charset="0"/>
+              <a:buChar char="•"/>
+              <a:defRPr sz="1400" kern="1200">
+                <a:solidFill>
+                  <a:schemeClr val="tx1"/>
+                </a:solidFill>
+                <a:latin typeface="+mn-lt"/>
+                <a:ea typeface="+mn-ea"/>
+                <a:cs typeface="+mn-cs"/>
+              </a:defRPr>
+            </a:lvl4pPr>
+            <a:lvl5pPr marL="1143000" indent="-228600" algn="l" defTabSz="914400" rtl="0" eaLnBrk="1" latinLnBrk="0" hangingPunct="1">
+              <a:lnSpc>
+                <a:spcPct val="120000"/>
+              </a:lnSpc>
+              <a:spcBef>
+                <a:spcPts val="500"/>
+              </a:spcBef>
+              <a:buFont typeface="Arial" panose="020B0604020202020204" pitchFamily="34" charset="0"/>
+              <a:buChar char="•"/>
+              <a:defRPr sz="1200" kern="1200">
+                <a:solidFill>
+                  <a:schemeClr val="tx1"/>
+                </a:solidFill>
+                <a:latin typeface="+mn-lt"/>
+                <a:ea typeface="+mn-ea"/>
+                <a:cs typeface="+mn-cs"/>
+              </a:defRPr>
+            </a:lvl5pPr>
+            <a:lvl6pPr marL="2514600" indent="-228600" algn="l" defTabSz="914400" rtl="0" eaLnBrk="1" latinLnBrk="0" hangingPunct="1">
+              <a:lnSpc>
+                <a:spcPct val="90000"/>
+              </a:lnSpc>
+              <a:spcBef>
+                <a:spcPts val="500"/>
+              </a:spcBef>
+              <a:buFont typeface="Arial" panose="020B0604020202020204" pitchFamily="34" charset="0"/>
+              <a:buChar char="•"/>
+              <a:defRPr sz="1800" kern="1200">
+                <a:solidFill>
+                  <a:schemeClr val="tx1"/>
+                </a:solidFill>
+                <a:latin typeface="+mn-lt"/>
+                <a:ea typeface="+mn-ea"/>
+                <a:cs typeface="+mn-cs"/>
+              </a:defRPr>
+            </a:lvl6pPr>
+            <a:lvl7pPr marL="2971800" indent="-228600" algn="l" defTabSz="914400" rtl="0" eaLnBrk="1" latinLnBrk="0" hangingPunct="1">
+              <a:lnSpc>
+                <a:spcPct val="90000"/>
+              </a:lnSpc>
+              <a:spcBef>
+                <a:spcPts val="500"/>
+              </a:spcBef>
+              <a:buFont typeface="Arial" panose="020B0604020202020204" pitchFamily="34" charset="0"/>
+              <a:buChar char="•"/>
+              <a:defRPr sz="1800" kern="1200">
+                <a:solidFill>
+                  <a:schemeClr val="tx1"/>
+                </a:solidFill>
+                <a:latin typeface="+mn-lt"/>
+                <a:ea typeface="+mn-ea"/>
+                <a:cs typeface="+mn-cs"/>
+              </a:defRPr>
+            </a:lvl7pPr>
+            <a:lvl8pPr marL="3429000" indent="-228600" algn="l" defTabSz="914400" rtl="0" eaLnBrk="1" latinLnBrk="0" hangingPunct="1">
+              <a:lnSpc>
+                <a:spcPct val="90000"/>
+              </a:lnSpc>
+              <a:spcBef>
+                <a:spcPts val="500"/>
+              </a:spcBef>
+              <a:buFont typeface="Arial" panose="020B0604020202020204" pitchFamily="34" charset="0"/>
+              <a:buChar char="•"/>
+              <a:defRPr sz="1800" kern="1200">
+                <a:solidFill>
+                  <a:schemeClr val="tx1"/>
+                </a:solidFill>
+                <a:latin typeface="+mn-lt"/>
+                <a:ea typeface="+mn-ea"/>
+                <a:cs typeface="+mn-cs"/>
+              </a:defRPr>
+            </a:lvl8pPr>
+            <a:lvl9pPr marL="3886200" indent="-228600" algn="l" defTabSz="914400" rtl="0" eaLnBrk="1" latinLnBrk="0" hangingPunct="1">
+              <a:lnSpc>
+                <a:spcPct val="90000"/>
+              </a:lnSpc>
+              <a:spcBef>
+                <a:spcPts val="500"/>
+              </a:spcBef>
+              <a:buFont typeface="Arial" panose="020B0604020202020204" pitchFamily="34" charset="0"/>
+              <a:buChar char="•"/>
+              <a:defRPr sz="1800" kern="1200">
+                <a:solidFill>
+                  <a:schemeClr val="tx1"/>
+                </a:solidFill>
+                <a:latin typeface="+mn-lt"/>
+                <a:ea typeface="+mn-ea"/>
+                <a:cs typeface="+mn-cs"/>
+              </a:defRPr>
+            </a:lvl9pPr>
+          </a:lstStyle>
+          <a:p>
+            <a:pPr marL="0" indent="0">
+              <a:buFont typeface="Arial" panose="020B0604020202020204" pitchFamily="34" charset="0"/>
+              <a:buNone/>
+            </a:pPr>
+            <a:r>
+              <a:rPr lang="en-GB" dirty="0"/>
+              <a:t>Fretting Transformer</a:t>
+            </a:r>
+          </a:p>
+          <a:p>
+            <a:r>
+              <a:rPr lang="en-GB" dirty="0"/>
+              <a:t>Translates music notation into guitar tablature</a:t>
+            </a:r>
+          </a:p>
+          <a:p>
+            <a:r>
+              <a:rPr lang="en-GB" dirty="0"/>
+              <a:t>Encoder-decoder model using T5 transformer architecture</a:t>
+            </a:r>
+          </a:p>
+          <a:p>
+            <a:r>
+              <a:rPr lang="en-GB" dirty="0"/>
+              <a:t>Predicts string fret combination</a:t>
+            </a:r>
+          </a:p>
+          <a:p>
+            <a:r>
+              <a:rPr lang="en-GB" dirty="0"/>
+              <a:t>Conditioned to work for different tunings and capo </a:t>
+            </a:r>
           </a:p>
         </p:txBody>
       </p:sp>
     </p:spTree>
     <p:extLst>
       <p:ext uri="{BB962C8B-B14F-4D97-AF65-F5344CB8AC3E}">
-        <p14:creationId xmlns:p14="http://schemas.microsoft.com/office/powerpoint/2010/main" val="3671412973"/>
+        <p14:creationId xmlns:p14="http://schemas.microsoft.com/office/powerpoint/2010/main" val="4270193216"/>
       </p:ext>
     </p:extLst>
   </p:cSld>
@@ -3865,7 +4476,7 @@
           <p:cNvPr id="2" name="Title 1">
             <a:extLst>
               <a:ext uri="{FF2B5EF4-FFF2-40B4-BE49-F238E27FC236}">
-                <a16:creationId xmlns:a16="http://schemas.microsoft.com/office/drawing/2014/main" id="{CAAF1E4D-9D79-AE75-533E-1F1B9AEA2BF6}"/>
+                <a16:creationId xmlns:a16="http://schemas.microsoft.com/office/drawing/2014/main" id="{0EF58947-F524-4559-37AC-94BD7D111181}"/>
               </a:ext>
             </a:extLst>
           </p:cNvPr>
@@ -3883,7 +4494,7 @@
           <a:p>
             <a:r>
               <a:rPr lang="en-GB" dirty="0"/>
-              <a:t>Basic Pitch + Preprocessing</a:t>
+              <a:t>Fretboard Mapping</a:t>
             </a:r>
           </a:p>
         </p:txBody>
@@ -3893,7 +4504,7 @@
           <p:cNvPr id="3" name="Content Placeholder 2">
             <a:extLst>
               <a:ext uri="{FF2B5EF4-FFF2-40B4-BE49-F238E27FC236}">
-                <a16:creationId xmlns:a16="http://schemas.microsoft.com/office/drawing/2014/main" id="{09A80076-0802-121B-D103-9D56EEA93F58}"/>
+                <a16:creationId xmlns:a16="http://schemas.microsoft.com/office/drawing/2014/main" id="{B3E5B730-C808-E536-C699-6D5393476667}"/>
               </a:ext>
             </a:extLst>
           </p:cNvPr>
@@ -3904,19 +4515,281 @@
             <p:ph idx="1"/>
           </p:nvPr>
         </p:nvSpPr>
-        <p:spPr/>
+        <p:spPr>
+          <a:xfrm>
+            <a:off x="612647" y="1715532"/>
+            <a:ext cx="5412233" cy="4593828"/>
+          </a:xfrm>
+        </p:spPr>
         <p:txBody>
           <a:bodyPr/>
           <a:lstStyle/>
           <a:p>
-            <a:endParaRPr lang="en-GB"/>
+            <a:r>
+              <a:rPr lang="en-GB" dirty="0"/>
+              <a:t>Current Fretboard Mapping:</a:t>
+            </a:r>
+          </a:p>
+          <a:p>
+            <a:pPr marL="571500" lvl="1" indent="-342900">
+              <a:buFont typeface="+mj-lt"/>
+              <a:buAutoNum type="arabicPeriod"/>
+            </a:pPr>
+            <a:r>
+              <a:rPr lang="en-GB" dirty="0"/>
+              <a:t>Greedy Heuristic</a:t>
+            </a:r>
+          </a:p>
+          <a:p>
+            <a:pPr marL="571500" lvl="1" indent="-342900">
+              <a:buFont typeface="+mj-lt"/>
+              <a:buAutoNum type="arabicPeriod"/>
+            </a:pPr>
+            <a:r>
+              <a:rPr lang="en-GB" dirty="0"/>
+              <a:t>Nearest fret distance</a:t>
+            </a:r>
+          </a:p>
+          <a:p>
+            <a:pPr marL="571500" lvl="1" indent="-342900">
+              <a:buFont typeface="+mj-lt"/>
+              <a:buAutoNum type="arabicPeriod"/>
+            </a:pPr>
+            <a:r>
+              <a:rPr lang="en-GB" dirty="0"/>
+              <a:t>No context (Does not factor in the previous or next fret)</a:t>
+            </a:r>
+          </a:p>
+          <a:p>
+            <a:pPr marL="571500" lvl="1" indent="-342900">
+              <a:buFont typeface="+mj-lt"/>
+              <a:buAutoNum type="arabicPeriod"/>
+            </a:pPr>
+            <a:r>
+              <a:rPr lang="en-GB" dirty="0"/>
+              <a:t>Simple and fast</a:t>
+            </a:r>
+          </a:p>
+        </p:txBody>
+      </p:sp>
+      <p:sp>
+        <p:nvSpPr>
+          <p:cNvPr id="4" name="Content Placeholder 2">
+            <a:extLst>
+              <a:ext uri="{FF2B5EF4-FFF2-40B4-BE49-F238E27FC236}">
+                <a16:creationId xmlns:a16="http://schemas.microsoft.com/office/drawing/2014/main" id="{A56FE509-410D-EECE-8D69-2338AC8E8A5C}"/>
+              </a:ext>
+            </a:extLst>
+          </p:cNvPr>
+          <p:cNvSpPr txBox="1">
+            <a:spLocks/>
+          </p:cNvSpPr>
+          <p:nvPr/>
+        </p:nvSpPr>
+        <p:spPr>
+          <a:xfrm>
+            <a:off x="7352563" y="1715532"/>
+            <a:ext cx="3472792" cy="4593828"/>
+          </a:xfrm>
+          <a:prstGeom prst="rect">
+            <a:avLst/>
+          </a:prstGeom>
+        </p:spPr>
+        <p:txBody>
+          <a:bodyPr vert="horz" lIns="91440" tIns="45720" rIns="91440" bIns="45720" rtlCol="0">
+            <a:normAutofit/>
+          </a:bodyPr>
+          <a:lstStyle>
+            <a:lvl1pPr marL="228600" indent="-228600" algn="l" defTabSz="914400" rtl="0" eaLnBrk="1" latinLnBrk="0" hangingPunct="1">
+              <a:lnSpc>
+                <a:spcPct val="120000"/>
+              </a:lnSpc>
+              <a:spcBef>
+                <a:spcPts val="1000"/>
+              </a:spcBef>
+              <a:buFont typeface="Arial" panose="020B0604020202020204" pitchFamily="34" charset="0"/>
+              <a:buChar char="•"/>
+              <a:defRPr sz="2000" kern="1200">
+                <a:solidFill>
+                  <a:schemeClr val="tx1"/>
+                </a:solidFill>
+                <a:latin typeface="+mn-lt"/>
+                <a:ea typeface="+mn-ea"/>
+                <a:cs typeface="+mn-cs"/>
+              </a:defRPr>
+            </a:lvl1pPr>
+            <a:lvl2pPr marL="457200" indent="-228600" algn="l" defTabSz="914400" rtl="0" eaLnBrk="1" latinLnBrk="0" hangingPunct="1">
+              <a:lnSpc>
+                <a:spcPct val="120000"/>
+              </a:lnSpc>
+              <a:spcBef>
+                <a:spcPts val="500"/>
+              </a:spcBef>
+              <a:buFont typeface="Arial" panose="020B0604020202020204" pitchFamily="34" charset="0"/>
+              <a:buChar char="•"/>
+              <a:defRPr sz="1800" kern="1200">
+                <a:solidFill>
+                  <a:schemeClr val="tx1"/>
+                </a:solidFill>
+                <a:latin typeface="+mn-lt"/>
+                <a:ea typeface="+mn-ea"/>
+                <a:cs typeface="+mn-cs"/>
+              </a:defRPr>
+            </a:lvl2pPr>
+            <a:lvl3pPr marL="685800" indent="-228600" algn="l" defTabSz="914400" rtl="0" eaLnBrk="1" latinLnBrk="0" hangingPunct="1">
+              <a:lnSpc>
+                <a:spcPct val="120000"/>
+              </a:lnSpc>
+              <a:spcBef>
+                <a:spcPts val="500"/>
+              </a:spcBef>
+              <a:buFont typeface="Arial" panose="020B0604020202020204" pitchFamily="34" charset="0"/>
+              <a:buChar char="•"/>
+              <a:defRPr sz="1600" kern="1200">
+                <a:solidFill>
+                  <a:schemeClr val="tx1"/>
+                </a:solidFill>
+                <a:latin typeface="+mn-lt"/>
+                <a:ea typeface="+mn-ea"/>
+                <a:cs typeface="+mn-cs"/>
+              </a:defRPr>
+            </a:lvl3pPr>
+            <a:lvl4pPr marL="914400" indent="-228600" algn="l" defTabSz="914400" rtl="0" eaLnBrk="1" latinLnBrk="0" hangingPunct="1">
+              <a:lnSpc>
+                <a:spcPct val="120000"/>
+              </a:lnSpc>
+              <a:spcBef>
+                <a:spcPts val="500"/>
+              </a:spcBef>
+              <a:buFont typeface="Arial" panose="020B0604020202020204" pitchFamily="34" charset="0"/>
+              <a:buChar char="•"/>
+              <a:defRPr sz="1400" kern="1200">
+                <a:solidFill>
+                  <a:schemeClr val="tx1"/>
+                </a:solidFill>
+                <a:latin typeface="+mn-lt"/>
+                <a:ea typeface="+mn-ea"/>
+                <a:cs typeface="+mn-cs"/>
+              </a:defRPr>
+            </a:lvl4pPr>
+            <a:lvl5pPr marL="1143000" indent="-228600" algn="l" defTabSz="914400" rtl="0" eaLnBrk="1" latinLnBrk="0" hangingPunct="1">
+              <a:lnSpc>
+                <a:spcPct val="120000"/>
+              </a:lnSpc>
+              <a:spcBef>
+                <a:spcPts val="500"/>
+              </a:spcBef>
+              <a:buFont typeface="Arial" panose="020B0604020202020204" pitchFamily="34" charset="0"/>
+              <a:buChar char="•"/>
+              <a:defRPr sz="1200" kern="1200">
+                <a:solidFill>
+                  <a:schemeClr val="tx1"/>
+                </a:solidFill>
+                <a:latin typeface="+mn-lt"/>
+                <a:ea typeface="+mn-ea"/>
+                <a:cs typeface="+mn-cs"/>
+              </a:defRPr>
+            </a:lvl5pPr>
+            <a:lvl6pPr marL="2514600" indent="-228600" algn="l" defTabSz="914400" rtl="0" eaLnBrk="1" latinLnBrk="0" hangingPunct="1">
+              <a:lnSpc>
+                <a:spcPct val="90000"/>
+              </a:lnSpc>
+              <a:spcBef>
+                <a:spcPts val="500"/>
+              </a:spcBef>
+              <a:buFont typeface="Arial" panose="020B0604020202020204" pitchFamily="34" charset="0"/>
+              <a:buChar char="•"/>
+              <a:defRPr sz="1800" kern="1200">
+                <a:solidFill>
+                  <a:schemeClr val="tx1"/>
+                </a:solidFill>
+                <a:latin typeface="+mn-lt"/>
+                <a:ea typeface="+mn-ea"/>
+                <a:cs typeface="+mn-cs"/>
+              </a:defRPr>
+            </a:lvl6pPr>
+            <a:lvl7pPr marL="2971800" indent="-228600" algn="l" defTabSz="914400" rtl="0" eaLnBrk="1" latinLnBrk="0" hangingPunct="1">
+              <a:lnSpc>
+                <a:spcPct val="90000"/>
+              </a:lnSpc>
+              <a:spcBef>
+                <a:spcPts val="500"/>
+              </a:spcBef>
+              <a:buFont typeface="Arial" panose="020B0604020202020204" pitchFamily="34" charset="0"/>
+              <a:buChar char="•"/>
+              <a:defRPr sz="1800" kern="1200">
+                <a:solidFill>
+                  <a:schemeClr val="tx1"/>
+                </a:solidFill>
+                <a:latin typeface="+mn-lt"/>
+                <a:ea typeface="+mn-ea"/>
+                <a:cs typeface="+mn-cs"/>
+              </a:defRPr>
+            </a:lvl7pPr>
+            <a:lvl8pPr marL="3429000" indent="-228600" algn="l" defTabSz="914400" rtl="0" eaLnBrk="1" latinLnBrk="0" hangingPunct="1">
+              <a:lnSpc>
+                <a:spcPct val="90000"/>
+              </a:lnSpc>
+              <a:spcBef>
+                <a:spcPts val="500"/>
+              </a:spcBef>
+              <a:buFont typeface="Arial" panose="020B0604020202020204" pitchFamily="34" charset="0"/>
+              <a:buChar char="•"/>
+              <a:defRPr sz="1800" kern="1200">
+                <a:solidFill>
+                  <a:schemeClr val="tx1"/>
+                </a:solidFill>
+                <a:latin typeface="+mn-lt"/>
+                <a:ea typeface="+mn-ea"/>
+                <a:cs typeface="+mn-cs"/>
+              </a:defRPr>
+            </a:lvl8pPr>
+            <a:lvl9pPr marL="3886200" indent="-228600" algn="l" defTabSz="914400" rtl="0" eaLnBrk="1" latinLnBrk="0" hangingPunct="1">
+              <a:lnSpc>
+                <a:spcPct val="90000"/>
+              </a:lnSpc>
+              <a:spcBef>
+                <a:spcPts val="500"/>
+              </a:spcBef>
+              <a:buFont typeface="Arial" panose="020B0604020202020204" pitchFamily="34" charset="0"/>
+              <a:buChar char="•"/>
+              <a:defRPr sz="1800" kern="1200">
+                <a:solidFill>
+                  <a:schemeClr val="tx1"/>
+                </a:solidFill>
+                <a:latin typeface="+mn-lt"/>
+                <a:ea typeface="+mn-ea"/>
+                <a:cs typeface="+mn-cs"/>
+              </a:defRPr>
+            </a:lvl9pPr>
+          </a:lstStyle>
+          <a:p>
+            <a:pPr marL="0" indent="0">
+              <a:buNone/>
+            </a:pPr>
+            <a:r>
+              <a:rPr lang="en-GB" dirty="0"/>
+              <a:t>Fretboard CNN (midi to fretboard)</a:t>
+            </a:r>
+          </a:p>
+          <a:p>
+            <a:r>
+              <a:rPr lang="en-GB" dirty="0"/>
+              <a:t>1-D Temporal Convolutional Network</a:t>
+            </a:r>
+          </a:p>
+          <a:p>
+            <a:endParaRPr lang="en-GB" dirty="0"/>
+          </a:p>
+          <a:p>
+            <a:endParaRPr lang="en-GB" dirty="0"/>
           </a:p>
         </p:txBody>
       </p:sp>
     </p:spTree>
     <p:extLst>
       <p:ext uri="{BB962C8B-B14F-4D97-AF65-F5344CB8AC3E}">
-        <p14:creationId xmlns:p14="http://schemas.microsoft.com/office/powerpoint/2010/main" val="2758349485"/>
+        <p14:creationId xmlns:p14="http://schemas.microsoft.com/office/powerpoint/2010/main" val="3124104137"/>
       </p:ext>
     </p:extLst>
   </p:cSld>
@@ -3956,7 +4829,7 @@
           <p:cNvPr id="2" name="Title 1">
             <a:extLst>
               <a:ext uri="{FF2B5EF4-FFF2-40B4-BE49-F238E27FC236}">
-                <a16:creationId xmlns:a16="http://schemas.microsoft.com/office/drawing/2014/main" id="{AF1DEDF5-C5C9-28BB-ACC7-F865864B39CF}"/>
+                <a16:creationId xmlns:a16="http://schemas.microsoft.com/office/drawing/2014/main" id="{B8218398-494E-FA07-F0B2-F5F640928F92}"/>
               </a:ext>
             </a:extLst>
           </p:cNvPr>
@@ -3974,7 +4847,7 @@
           <a:p>
             <a:r>
               <a:rPr lang="en-GB" dirty="0"/>
-              <a:t>Basic Pitch + Postprocessing</a:t>
+              <a:t>Basic Pitch (Control)</a:t>
             </a:r>
           </a:p>
         </p:txBody>
@@ -3984,7 +4857,7 @@
           <p:cNvPr id="3" name="Content Placeholder 2">
             <a:extLst>
               <a:ext uri="{FF2B5EF4-FFF2-40B4-BE49-F238E27FC236}">
-                <a16:creationId xmlns:a16="http://schemas.microsoft.com/office/drawing/2014/main" id="{4FFFAB76-894E-E1E3-2852-ABD9A28358F4}"/>
+                <a16:creationId xmlns:a16="http://schemas.microsoft.com/office/drawing/2014/main" id="{E85D6C78-A73B-07E2-DB5B-377EA74CEF88}"/>
               </a:ext>
             </a:extLst>
           </p:cNvPr>
@@ -3997,17 +4870,88 @@
         </p:nvSpPr>
         <p:spPr/>
         <p:txBody>
-          <a:bodyPr/>
-          <a:lstStyle/>
-          <a:p>
-            <a:endParaRPr lang="en-GB"/>
+          <a:bodyPr>
+            <a:normAutofit fontScale="77500" lnSpcReduction="20000"/>
+          </a:bodyPr>
+          <a:lstStyle/>
+          <a:p>
+            <a:r>
+              <a:rPr lang="en-GB" dirty="0"/>
+              <a:t>Processing Evaluation...</a:t>
+            </a:r>
+          </a:p>
+          <a:p>
+            <a:r>
+              <a:rPr lang="en-GB" dirty="0"/>
+              <a:t>=======================================================================</a:t>
+            </a:r>
+          </a:p>
+          <a:p>
+            <a:r>
+              <a:rPr lang="en-GB" dirty="0"/>
+              <a:t>Total number of actual notes: 151</a:t>
+            </a:r>
+          </a:p>
+          <a:p>
+            <a:r>
+              <a:rPr lang="en-GB" dirty="0"/>
+              <a:t>Total number of predicted notes: 146</a:t>
+            </a:r>
+          </a:p>
+          <a:p>
+            <a:r>
+              <a:rPr lang="en-GB" dirty="0"/>
+              <a:t>•••••</a:t>
+            </a:r>
+          </a:p>
+          <a:p>
+            <a:r>
+              <a:rPr lang="en-GB" dirty="0"/>
+              <a:t>True Positives: 96</a:t>
+            </a:r>
+          </a:p>
+          <a:p>
+            <a:r>
+              <a:rPr lang="en-GB" dirty="0"/>
+              <a:t>False Positives: 50</a:t>
+            </a:r>
+          </a:p>
+          <a:p>
+            <a:r>
+              <a:rPr lang="en-GB" dirty="0"/>
+              <a:t>False Negatives: 55</a:t>
+            </a:r>
+          </a:p>
+          <a:p>
+            <a:r>
+              <a:rPr lang="en-GB" dirty="0"/>
+              <a:t>•••••</a:t>
+            </a:r>
+          </a:p>
+          <a:p>
+            <a:r>
+              <a:rPr lang="en-GB" dirty="0"/>
+              <a:t>The precision of the model: 0.6575</a:t>
+            </a:r>
+          </a:p>
+          <a:p>
+            <a:r>
+              <a:rPr lang="en-GB" dirty="0"/>
+              <a:t>The recall of the model: 0.6358</a:t>
+            </a:r>
+          </a:p>
+          <a:p>
+            <a:r>
+              <a:rPr lang="en-GB" dirty="0"/>
+              <a:t>The F1-Score of the model: 0.6465</a:t>
+            </a:r>
           </a:p>
         </p:txBody>
       </p:sp>
     </p:spTree>
     <p:extLst>
       <p:ext uri="{BB962C8B-B14F-4D97-AF65-F5344CB8AC3E}">
-        <p14:creationId xmlns:p14="http://schemas.microsoft.com/office/powerpoint/2010/main" val="246204675"/>
+        <p14:creationId xmlns:p14="http://schemas.microsoft.com/office/powerpoint/2010/main" val="3671412973"/>
       </p:ext>
     </p:extLst>
   </p:cSld>
@@ -4047,7 +4991,7 @@
           <p:cNvPr id="2" name="Title 1">
             <a:extLst>
               <a:ext uri="{FF2B5EF4-FFF2-40B4-BE49-F238E27FC236}">
-                <a16:creationId xmlns:a16="http://schemas.microsoft.com/office/drawing/2014/main" id="{A5A91FE7-FBF4-7BA5-92F8-B29FA28C8F7B}"/>
+                <a16:creationId xmlns:a16="http://schemas.microsoft.com/office/drawing/2014/main" id="{CAAF1E4D-9D79-AE75-533E-1F1B9AEA2BF6}"/>
               </a:ext>
             </a:extLst>
           </p:cNvPr>
@@ -4065,7 +5009,7 @@
           <a:p>
             <a:r>
               <a:rPr lang="en-GB" dirty="0"/>
-              <a:t>Basic Pitch + Pre + Postprocessing</a:t>
+              <a:t>Basic Pitch + Preprocessing</a:t>
             </a:r>
           </a:p>
         </p:txBody>
@@ -4075,7 +5019,7 @@
           <p:cNvPr id="3" name="Content Placeholder 2">
             <a:extLst>
               <a:ext uri="{FF2B5EF4-FFF2-40B4-BE49-F238E27FC236}">
-                <a16:creationId xmlns:a16="http://schemas.microsoft.com/office/drawing/2014/main" id="{036A883B-8459-586F-7D7B-767180889695}"/>
+                <a16:creationId xmlns:a16="http://schemas.microsoft.com/office/drawing/2014/main" id="{09A80076-0802-121B-D103-9D56EEA93F58}"/>
               </a:ext>
             </a:extLst>
           </p:cNvPr>
@@ -4088,17 +5032,88 @@
         </p:nvSpPr>
         <p:spPr/>
         <p:txBody>
-          <a:bodyPr/>
-          <a:lstStyle/>
-          <a:p>
-            <a:endParaRPr lang="en-GB" dirty="0"/>
+          <a:bodyPr>
+            <a:normAutofit fontScale="77500" lnSpcReduction="20000"/>
+          </a:bodyPr>
+          <a:lstStyle/>
+          <a:p>
+            <a:r>
+              <a:rPr lang="en-GB" dirty="0"/>
+              <a:t>Processing Evaluation...</a:t>
+            </a:r>
+          </a:p>
+          <a:p>
+            <a:r>
+              <a:rPr lang="en-GB" dirty="0"/>
+              <a:t>=======================================================================</a:t>
+            </a:r>
+          </a:p>
+          <a:p>
+            <a:r>
+              <a:rPr lang="en-GB" dirty="0"/>
+              <a:t>Total number of actual notes: 151</a:t>
+            </a:r>
+          </a:p>
+          <a:p>
+            <a:r>
+              <a:rPr lang="en-GB" dirty="0"/>
+              <a:t>Total number of predicted notes: 109</a:t>
+            </a:r>
+          </a:p>
+          <a:p>
+            <a:r>
+              <a:rPr lang="en-GB" dirty="0"/>
+              <a:t>•••••</a:t>
+            </a:r>
+          </a:p>
+          <a:p>
+            <a:r>
+              <a:rPr lang="en-GB" dirty="0"/>
+              <a:t>True Positives: 64</a:t>
+            </a:r>
+          </a:p>
+          <a:p>
+            <a:r>
+              <a:rPr lang="en-GB" dirty="0"/>
+              <a:t>False Positives: 45</a:t>
+            </a:r>
+          </a:p>
+          <a:p>
+            <a:r>
+              <a:rPr lang="en-GB" dirty="0"/>
+              <a:t>False Negatives: 87</a:t>
+            </a:r>
+          </a:p>
+          <a:p>
+            <a:r>
+              <a:rPr lang="en-GB" dirty="0"/>
+              <a:t>•••••</a:t>
+            </a:r>
+          </a:p>
+          <a:p>
+            <a:r>
+              <a:rPr lang="en-GB" dirty="0"/>
+              <a:t>The precision of the model: 0.5872</a:t>
+            </a:r>
+          </a:p>
+          <a:p>
+            <a:r>
+              <a:rPr lang="en-GB" dirty="0"/>
+              <a:t>The recall of the model: 0.4238</a:t>
+            </a:r>
+          </a:p>
+          <a:p>
+            <a:r>
+              <a:rPr lang="en-GB" dirty="0"/>
+              <a:t>The F1-Score of the model: 0.4923</a:t>
+            </a:r>
           </a:p>
         </p:txBody>
       </p:sp>
     </p:spTree>
     <p:extLst>
       <p:ext uri="{BB962C8B-B14F-4D97-AF65-F5344CB8AC3E}">
-        <p14:creationId xmlns:p14="http://schemas.microsoft.com/office/powerpoint/2010/main" val="3444432514"/>
+        <p14:creationId xmlns:p14="http://schemas.microsoft.com/office/powerpoint/2010/main" val="2758349485"/>
       </p:ext>
     </p:extLst>
   </p:cSld>
@@ -4138,7 +5153,7 @@
           <p:cNvPr id="2" name="Title 1">
             <a:extLst>
               <a:ext uri="{FF2B5EF4-FFF2-40B4-BE49-F238E27FC236}">
-                <a16:creationId xmlns:a16="http://schemas.microsoft.com/office/drawing/2014/main" id="{0EF58947-F524-4559-37AC-94BD7D111181}"/>
+                <a16:creationId xmlns:a16="http://schemas.microsoft.com/office/drawing/2014/main" id="{AF1DEDF5-C5C9-28BB-ACC7-F865864B39CF}"/>
               </a:ext>
             </a:extLst>
           </p:cNvPr>
@@ -4156,7 +5171,7 @@
           <a:p>
             <a:r>
               <a:rPr lang="en-GB" dirty="0"/>
-              <a:t>Fretboard Mapping</a:t>
+              <a:t>Basic Pitch + Postprocessing</a:t>
             </a:r>
           </a:p>
         </p:txBody>
@@ -4166,7 +5181,7 @@
           <p:cNvPr id="3" name="Content Placeholder 2">
             <a:extLst>
               <a:ext uri="{FF2B5EF4-FFF2-40B4-BE49-F238E27FC236}">
-                <a16:creationId xmlns:a16="http://schemas.microsoft.com/office/drawing/2014/main" id="{B3E5B730-C808-E536-C699-6D5393476667}"/>
+                <a16:creationId xmlns:a16="http://schemas.microsoft.com/office/drawing/2014/main" id="{4FFFAB76-894E-E1E3-2852-ABD9A28358F4}"/>
               </a:ext>
             </a:extLst>
           </p:cNvPr>
@@ -4177,59 +5192,85 @@
             <p:ph idx="1"/>
           </p:nvPr>
         </p:nvSpPr>
-        <p:spPr>
-          <a:xfrm>
-            <a:off x="612647" y="1715532"/>
-            <a:ext cx="5412233" cy="4593828"/>
-          </a:xfrm>
-        </p:spPr>
-        <p:txBody>
-          <a:bodyPr/>
-          <a:lstStyle/>
-          <a:p>
-            <a:r>
-              <a:rPr lang="en-GB" dirty="0"/>
-              <a:t>Current Fretboard Mapping:</a:t>
-            </a:r>
-          </a:p>
-          <a:p>
-            <a:pPr marL="571500" lvl="1" indent="-342900">
-              <a:buFont typeface="+mj-lt"/>
-              <a:buAutoNum type="arabicPeriod"/>
+        <p:spPr/>
+        <p:txBody>
+          <a:bodyPr>
+            <a:normAutofit fontScale="77500" lnSpcReduction="20000"/>
+          </a:bodyPr>
+          <a:lstStyle/>
+          <a:p>
+            <a:pPr marL="0" indent="0">
+              <a:buNone/>
             </a:pPr>
             <a:r>
               <a:rPr lang="en-GB" dirty="0"/>
-              <a:t>Greedy Heuristic</a:t>
-            </a:r>
-          </a:p>
-          <a:p>
-            <a:pPr marL="571500" lvl="1" indent="-342900">
-              <a:buFont typeface="+mj-lt"/>
-              <a:buAutoNum type="arabicPeriod"/>
-            </a:pPr>
-            <a:r>
-              <a:rPr lang="en-GB" dirty="0"/>
-              <a:t>Nearest fret distance</a:t>
-            </a:r>
-          </a:p>
-          <a:p>
-            <a:pPr marL="571500" lvl="1" indent="-342900">
-              <a:buFont typeface="+mj-lt"/>
-              <a:buAutoNum type="arabicPeriod"/>
-            </a:pPr>
-            <a:r>
-              <a:rPr lang="en-GB" dirty="0"/>
-              <a:t>No context (Does not factor in the previous or next fret)</a:t>
-            </a:r>
-          </a:p>
-          <a:p>
-            <a:pPr marL="571500" lvl="1" indent="-342900">
-              <a:buFont typeface="+mj-lt"/>
-              <a:buAutoNum type="arabicPeriod"/>
-            </a:pPr>
-            <a:r>
-              <a:rPr lang="en-GB" dirty="0"/>
-              <a:t>Simple and fast</a:t>
+              <a:t>Processing Evaluation...</a:t>
+            </a:r>
+          </a:p>
+          <a:p>
+            <a:r>
+              <a:rPr lang="en-GB" dirty="0"/>
+              <a:t>=======================================================================</a:t>
+            </a:r>
+          </a:p>
+          <a:p>
+            <a:r>
+              <a:rPr lang="en-GB" dirty="0"/>
+              <a:t>Total number of actual notes: 151</a:t>
+            </a:r>
+          </a:p>
+          <a:p>
+            <a:r>
+              <a:rPr lang="en-GB" dirty="0"/>
+              <a:t>Total number of predicted notes: 111</a:t>
+            </a:r>
+          </a:p>
+          <a:p>
+            <a:r>
+              <a:rPr lang="en-GB" dirty="0"/>
+              <a:t>•••••</a:t>
+            </a:r>
+          </a:p>
+          <a:p>
+            <a:r>
+              <a:rPr lang="en-GB" dirty="0"/>
+              <a:t>True Positives: 84</a:t>
+            </a:r>
+          </a:p>
+          <a:p>
+            <a:r>
+              <a:rPr lang="en-GB" dirty="0"/>
+              <a:t>False Positives: 27</a:t>
+            </a:r>
+          </a:p>
+          <a:p>
+            <a:r>
+              <a:rPr lang="en-GB" dirty="0"/>
+              <a:t>False Negatives: 67</a:t>
+            </a:r>
+          </a:p>
+          <a:p>
+            <a:r>
+              <a:rPr lang="en-GB" dirty="0"/>
+              <a:t>•••••</a:t>
+            </a:r>
+          </a:p>
+          <a:p>
+            <a:r>
+              <a:rPr lang="en-GB" dirty="0"/>
+              <a:t>The precision of the model: 0.7568</a:t>
+            </a:r>
+          </a:p>
+          <a:p>
+            <a:r>
+              <a:rPr lang="en-GB" dirty="0"/>
+              <a:t>The recall of the model: 0.5563</a:t>
+            </a:r>
+          </a:p>
+          <a:p>
+            <a:r>
+              <a:rPr lang="en-GB" dirty="0"/>
+              <a:t>The F1-Score of the model: 0.6412</a:t>
             </a:r>
           </a:p>
         </p:txBody>
@@ -4237,7 +5278,7 @@
     </p:spTree>
     <p:extLst>
       <p:ext uri="{BB962C8B-B14F-4D97-AF65-F5344CB8AC3E}">
-        <p14:creationId xmlns:p14="http://schemas.microsoft.com/office/powerpoint/2010/main" val="3124104137"/>
+        <p14:creationId xmlns:p14="http://schemas.microsoft.com/office/powerpoint/2010/main" val="246204675"/>
       </p:ext>
     </p:extLst>
   </p:cSld>
@@ -4250,6 +5291,14 @@
 <file path=ppt/slides/slide8.xml><?xml version="1.0" encoding="utf-8"?>
 <p:sld xmlns:a="http://schemas.openxmlformats.org/drawingml/2006/main" xmlns:r="http://schemas.openxmlformats.org/officeDocument/2006/relationships" xmlns:p="http://schemas.openxmlformats.org/presentationml/2006/main">
   <p:cSld>
+    <p:bg>
+      <p:bgPr>
+        <a:solidFill>
+          <a:srgbClr val="FFFCF7"/>
+        </a:solidFill>
+        <a:effectLst/>
+      </p:bgPr>
+    </p:bg>
     <p:spTree>
       <p:nvGrpSpPr>
         <p:cNvPr id="1" name=""/>
@@ -4269,6 +5318,156 @@
           <p:cNvPr id="2" name="Title 1">
             <a:extLst>
               <a:ext uri="{FF2B5EF4-FFF2-40B4-BE49-F238E27FC236}">
+                <a16:creationId xmlns:a16="http://schemas.microsoft.com/office/drawing/2014/main" id="{A5A91FE7-FBF4-7BA5-92F8-B29FA28C8F7B}"/>
+              </a:ext>
+            </a:extLst>
+          </p:cNvPr>
+          <p:cNvSpPr>
+            <a:spLocks noGrp="1"/>
+          </p:cNvSpPr>
+          <p:nvPr>
+            <p:ph type="title"/>
+          </p:nvPr>
+        </p:nvSpPr>
+        <p:spPr/>
+        <p:txBody>
+          <a:bodyPr/>
+          <a:lstStyle/>
+          <a:p>
+            <a:r>
+              <a:rPr lang="en-GB" dirty="0"/>
+              <a:t>Basic Pitch + Pre + Postprocessing</a:t>
+            </a:r>
+          </a:p>
+        </p:txBody>
+      </p:sp>
+      <p:sp>
+        <p:nvSpPr>
+          <p:cNvPr id="3" name="Content Placeholder 2">
+            <a:extLst>
+              <a:ext uri="{FF2B5EF4-FFF2-40B4-BE49-F238E27FC236}">
+                <a16:creationId xmlns:a16="http://schemas.microsoft.com/office/drawing/2014/main" id="{036A883B-8459-586F-7D7B-767180889695}"/>
+              </a:ext>
+            </a:extLst>
+          </p:cNvPr>
+          <p:cNvSpPr>
+            <a:spLocks noGrp="1"/>
+          </p:cNvSpPr>
+          <p:nvPr>
+            <p:ph idx="1"/>
+          </p:nvPr>
+        </p:nvSpPr>
+        <p:spPr/>
+        <p:txBody>
+          <a:bodyPr>
+            <a:normAutofit fontScale="92500" lnSpcReduction="10000"/>
+          </a:bodyPr>
+          <a:lstStyle/>
+          <a:p>
+            <a:r>
+              <a:rPr lang="en-GB" dirty="0"/>
+              <a:t>Processing Evaluation...</a:t>
+            </a:r>
+          </a:p>
+          <a:p>
+            <a:r>
+              <a:rPr lang="en-GB" dirty="0"/>
+              <a:t>======================================================================</a:t>
+            </a:r>
+          </a:p>
+          <a:p>
+            <a:r>
+              <a:rPr lang="en-GB" dirty="0"/>
+              <a:t>•••••</a:t>
+            </a:r>
+          </a:p>
+          <a:p>
+            <a:r>
+              <a:rPr lang="en-GB" dirty="0"/>
+              <a:t>True Positives: 58</a:t>
+            </a:r>
+          </a:p>
+          <a:p>
+            <a:r>
+              <a:rPr lang="en-GB" dirty="0"/>
+              <a:t>False Positives: 21</a:t>
+            </a:r>
+          </a:p>
+          <a:p>
+            <a:r>
+              <a:rPr lang="en-GB" dirty="0"/>
+              <a:t>False Negatives: 93</a:t>
+            </a:r>
+          </a:p>
+          <a:p>
+            <a:r>
+              <a:rPr lang="en-GB" dirty="0"/>
+              <a:t>•••••</a:t>
+            </a:r>
+          </a:p>
+          <a:p>
+            <a:r>
+              <a:rPr lang="en-GB" dirty="0"/>
+              <a:t>The precision of the model: 0.7342</a:t>
+            </a:r>
+          </a:p>
+          <a:p>
+            <a:r>
+              <a:rPr lang="en-GB" dirty="0"/>
+              <a:t>The recall of the model: 0.3841</a:t>
+            </a:r>
+          </a:p>
+          <a:p>
+            <a:r>
+              <a:rPr lang="en-GB" dirty="0"/>
+              <a:t>The F1-Score of the model: 0.5043</a:t>
+            </a:r>
+          </a:p>
+        </p:txBody>
+      </p:sp>
+    </p:spTree>
+    <p:extLst>
+      <p:ext uri="{BB962C8B-B14F-4D97-AF65-F5344CB8AC3E}">
+        <p14:creationId xmlns:p14="http://schemas.microsoft.com/office/powerpoint/2010/main" val="3444432514"/>
+      </p:ext>
+    </p:extLst>
+  </p:cSld>
+  <p:clrMapOvr>
+    <a:masterClrMapping/>
+  </p:clrMapOvr>
+</p:sld>
+</file>
+
+<file path=ppt/slides/slide9.xml><?xml version="1.0" encoding="utf-8"?>
+<p:sld xmlns:a="http://schemas.openxmlformats.org/drawingml/2006/main" xmlns:r="http://schemas.openxmlformats.org/officeDocument/2006/relationships" xmlns:p="http://schemas.openxmlformats.org/presentationml/2006/main">
+  <p:cSld>
+    <p:bg>
+      <p:bgPr>
+        <a:solidFill>
+          <a:srgbClr val="FFFCF7"/>
+        </a:solidFill>
+        <a:effectLst/>
+      </p:bgPr>
+    </p:bg>
+    <p:spTree>
+      <p:nvGrpSpPr>
+        <p:cNvPr id="1" name=""/>
+        <p:cNvGrpSpPr/>
+        <p:nvPr/>
+      </p:nvGrpSpPr>
+      <p:grpSpPr>
+        <a:xfrm>
+          <a:off x="0" y="0"/>
+          <a:ext cx="0" cy="0"/>
+          <a:chOff x="0" y="0"/>
+          <a:chExt cx="0" cy="0"/>
+        </a:xfrm>
+      </p:grpSpPr>
+      <p:sp>
+        <p:nvSpPr>
+          <p:cNvPr id="2" name="Title 1">
+            <a:extLst>
+              <a:ext uri="{FF2B5EF4-FFF2-40B4-BE49-F238E27FC236}">
                 <a16:creationId xmlns:a16="http://schemas.microsoft.com/office/drawing/2014/main" id="{8E78EE39-0C32-8F77-BC90-0E1ECD3A5FB1}"/>
               </a:ext>
             </a:extLst>
@@ -4287,17 +5486,17 @@
           <a:p>
             <a:r>
               <a:rPr lang="en-GB" dirty="0"/>
-              <a:t>Evaluating Metric for Fretboard Mapping</a:t>
-            </a:r>
-          </a:p>
-        </p:txBody>
-      </p:sp>
-      <p:sp>
-        <p:nvSpPr>
-          <p:cNvPr id="3" name="Content Placeholder 2">
-            <a:extLst>
-              <a:ext uri="{FF2B5EF4-FFF2-40B4-BE49-F238E27FC236}">
-                <a16:creationId xmlns:a16="http://schemas.microsoft.com/office/drawing/2014/main" id="{36108431-E789-2B96-F51B-8B06A673B9AB}"/>
+              <a:t>Next Plan	</a:t>
+            </a:r>
+          </a:p>
+        </p:txBody>
+      </p:sp>
+      <p:sp>
+        <p:nvSpPr>
+          <p:cNvPr id="5" name="Content Placeholder 4">
+            <a:extLst>
+              <a:ext uri="{FF2B5EF4-FFF2-40B4-BE49-F238E27FC236}">
+                <a16:creationId xmlns:a16="http://schemas.microsoft.com/office/drawing/2014/main" id="{D11B7D9C-7579-8FE5-BC34-C76589C3C068}"/>
               </a:ext>
             </a:extLst>
           </p:cNvPr>
@@ -4312,6 +5511,35 @@
         <p:txBody>
           <a:bodyPr/>
           <a:lstStyle/>
+          <a:p>
+            <a:r>
+              <a:rPr lang="en-GB" dirty="0"/>
+              <a:t>Evaluation metrics for mapping </a:t>
+            </a:r>
+          </a:p>
+          <a:p>
+            <a:r>
+              <a:rPr lang="en-GB" dirty="0"/>
+              <a:t>Use a Pre-Trained Model (fine tuning)</a:t>
+            </a:r>
+          </a:p>
+          <a:p>
+            <a:r>
+              <a:rPr lang="en-GB" dirty="0"/>
+              <a:t>Classification of guitar techniques</a:t>
+            </a:r>
+          </a:p>
+          <a:p>
+            <a:r>
+              <a:rPr lang="en-GB" dirty="0"/>
+              <a:t>Light </a:t>
+            </a:r>
+            <a:r>
+              <a:rPr lang="en-GB"/>
+              <a:t>weight version to Tart?</a:t>
+            </a:r>
+            <a:endParaRPr lang="en-GB" dirty="0"/>
+          </a:p>
           <a:p>
             <a:endParaRPr lang="en-GB" dirty="0"/>
           </a:p>

</xml_diff>